<commit_message>
Add Chapter 9.3: Cloud-Native Agent Builders at a Glance
Covers Amazon Bedrock AgentCore, Microsoft Foundry Agent Service, and
Google's Gemini Enterprise Agent Platform, all three renamed or absorbed
an older product within roughly the last twelve months. Includes a
matching slide deck, glossary entries, and the Phase 9 index update.

Also retroactively corrects Chapter 9.1's two now-outdated platform
names (AWS Bedrock Agents -> Amazon Bedrock AgentCore, Azure AI Foundry
Agent Service -> Microsoft Foundry Agent Service) in its prose,
comparison table, glossary entry, and deck, so the chapter's own point
about fast-moving naming does not undercut itself.
</commit_message>
<xml_diff>
--- a/decks/9.1-Why-an-Ecosystem-Landscape-Chapter-Slides.pptx
+++ b/decks/9.1-Why-an-Ecosystem-Landscape-Chapter-Slides.pptx
@@ -3896,7 +3896,7 @@
                   <a:srgbClr val="6B7280"/>
                 </a:solidFill>
               </a:rPr>
-              <a:t>  a hosted, managed product a cloud vendor operates for you (AWS Bedrock Agents, Azure AI Foundry Agent Service).</a:t>
+              <a:t>  a hosted, managed product a cloud vendor operates for you (Amazon Bedrock AgentCore, Microsoft Foundry Agent Service).</a:t>
             </a:r>
           </a:p>
           <a:p>
@@ -4497,7 +4497,7 @@
                             <a:srgbClr val="1F2D3D"/>
                           </a:solidFill>
                         </a:rPr>
-                        <a:t>AWS Bedrock Agents, Azure AI Foundry</a:t>
+                        <a:t>Amazon Bedrock AgentCore, MS Foundry Agent Service</a:t>
                       </a:r>
                     </a:p>
                   </a:txBody>

</xml_diff>